<commit_message>
Restructure domain notes and align docs with slides
</commit_message>
<xml_diff>
--- a/slides/template-deep-learning.pptx
+++ b/slides/template-deep-learning.pptx
@@ -1259,8 +1259,8 @@
         </p:nvSpPr>
         <p:spPr>
           <a:xfrm>
-            <a:off x="7559999" y="2822714"/>
-            <a:ext cx="4397835" cy="3806859"/>
+            <a:off x="9477031" y="4162230"/>
+            <a:ext cx="2520000" cy="2520000"/>
           </a:xfrm>
         </p:spPr>
         <p:txBody>

</xml_diff>